<commit_message>
update docs part 2
</commit_message>
<xml_diff>
--- a/presentation/GO-Präsi.pptx
+++ b/presentation/GO-Präsi.pptx
@@ -2481,10 +2481,10 @@
         <a:lstStyle/>
         <a:p>
           <a:r>
-            <a:rPr lang="de-CH"/>
+            <a:rPr lang="de-CH" dirty="0"/>
             <a:t>Typ wird über Struktur / Methoden erkannt</a:t>
           </a:r>
-          <a:endParaRPr lang="en-US"/>
+          <a:endParaRPr lang="en-US" dirty="0"/>
         </a:p>
       </dgm:t>
     </dgm:pt>
@@ -3118,9 +3118,9 @@
     <dgm:cxn modelId="{AE86C032-8682-4BF1-BB68-6ADD0BB41A54}" type="presOf" srcId="{1AB3C50A-FCBF-4AEF-8D4D-858CFA132352}" destId="{983E5E44-A04E-4C45-A005-9093A3A3B4CB}" srcOrd="0" destOrd="0" presId="urn:microsoft.com/office/officeart/2008/layout/LinedList"/>
     <dgm:cxn modelId="{9F6C3140-939F-4D3D-B0B7-B516E250A006}" type="presOf" srcId="{34C133A9-4E63-474C-93DD-32EDE76F4D16}" destId="{E478383E-DAE8-4801-A304-9A3B4EF375BF}" srcOrd="0" destOrd="0" presId="urn:microsoft.com/office/officeart/2008/layout/LinedList"/>
     <dgm:cxn modelId="{88749E44-69B6-44A7-84E1-1FCE1F2B1FA3}" srcId="{A53334CF-783B-42FC-B557-FFF66E2E05D2}" destId="{CC8160C3-CBEA-4B2C-A4FC-ADB710CB47EF}" srcOrd="1" destOrd="0" parTransId="{6C195E6E-746B-4A1A-B6A2-0D8E1F3C96F3}" sibTransId="{03BB51D0-D42A-486F-91B9-A792572A8A53}"/>
-    <dgm:cxn modelId="{FC356D67-8C98-4512-9C59-5C82B1CE4E88}" srcId="{0FEA5DDF-8CA7-4CF6-8462-91985CBA858E}" destId="{00FCB9CF-8E88-4656-B329-0EF4CD576DB1}" srcOrd="1" destOrd="0" parTransId="{9CC6512F-47BA-481F-A700-1714B90A213B}" sibTransId="{2426879B-88A3-42A4-8EDF-1BA13727DBB9}"/>
     <dgm:cxn modelId="{73FD3553-7C9A-4430-B54F-6EEDA45EBDF9}" type="presOf" srcId="{CC8160C3-CBEA-4B2C-A4FC-ADB710CB47EF}" destId="{53FC0197-4AFD-407F-8768-2842A6B8D732}" srcOrd="0" destOrd="0" presId="urn:microsoft.com/office/officeart/2008/layout/LinedList"/>
     <dgm:cxn modelId="{F43D4F56-65EA-49BB-849E-6F31E2BDE7F9}" type="presOf" srcId="{6D31FA9B-5825-44D6-A7B7-A7E13CF76391}" destId="{9A6315B2-11EA-415B-AEF6-96A923313A4F}" srcOrd="0" destOrd="0" presId="urn:microsoft.com/office/officeart/2008/layout/LinedList"/>
+    <dgm:cxn modelId="{FC356D67-8C98-4512-9C59-5C82B1CE4E88}" srcId="{0FEA5DDF-8CA7-4CF6-8462-91985CBA858E}" destId="{00FCB9CF-8E88-4656-B329-0EF4CD576DB1}" srcOrd="1" destOrd="0" parTransId="{9CC6512F-47BA-481F-A700-1714B90A213B}" sibTransId="{2426879B-88A3-42A4-8EDF-1BA13727DBB9}"/>
     <dgm:cxn modelId="{C5292181-7D3D-42D3-9D04-BE4E6F830736}" srcId="{0FEA5DDF-8CA7-4CF6-8462-91985CBA858E}" destId="{34C133A9-4E63-474C-93DD-32EDE76F4D16}" srcOrd="0" destOrd="0" parTransId="{1997A60F-C4B1-47EF-89EF-A6A6777F3A3D}" sibTransId="{4B2380FF-F43D-4B58-9915-DF12CA02B093}"/>
     <dgm:cxn modelId="{71545983-048A-44B1-B54D-4D6E803E9FD3}" srcId="{94581A3B-ABA8-42E0-9F65-99AE66091771}" destId="{0FEA5DDF-8CA7-4CF6-8462-91985CBA858E}" srcOrd="0" destOrd="0" parTransId="{3A254884-79B9-4FED-893D-1A4FCEBD01A6}" sibTransId="{75CDBFEE-6D15-45F7-8507-73DA1B0A12EC}"/>
     <dgm:cxn modelId="{C0EEDA90-DFDB-4338-B792-6668EFAB71DD}" type="presOf" srcId="{424F5155-6842-428C-8550-8AF1A35C714E}" destId="{2DEF67C1-3561-45C4-A1E3-82FE8B53EBE0}" srcOrd="0" destOrd="0" presId="urn:microsoft.com/office/officeart/2008/layout/LinedList"/>
@@ -4269,11 +4269,11 @@
     <dgm:cxn modelId="{6E0EDF32-D016-4BF3-812B-5934D4D47E86}" srcId="{51ADB69E-CEEF-44BF-B03A-EB79CD9E8062}" destId="{BC4AB904-5D13-426C-89D9-40D36AE51705}" srcOrd="4" destOrd="0" parTransId="{280B05C2-E5AF-456A-BE28-4991504969A6}" sibTransId="{49D1F00D-37F1-439F-ADFF-6F9663F5E7E7}"/>
     <dgm:cxn modelId="{80845E34-250A-4AB4-BE3E-D84544F5203D}" type="presOf" srcId="{44DC462A-0AC9-4248-A8AA-10B02822AAED}" destId="{4F178F7E-E77E-4653-9CB2-309E78EB0CD7}" srcOrd="0" destOrd="0" presId="urn:microsoft.com/office/officeart/2008/layout/LinedList"/>
     <dgm:cxn modelId="{5C1C6D40-C7E6-40C5-AA08-2545D93119F2}" type="presOf" srcId="{F5C01579-7F57-4979-A7F0-69FC1B3A98FC}" destId="{55A47832-5E60-409E-927E-D470B0ACEFC1}" srcOrd="0" destOrd="0" presId="urn:microsoft.com/office/officeart/2008/layout/LinedList"/>
+    <dgm:cxn modelId="{4B4B9D53-D3B2-49CA-835A-749A3CC976F2}" type="presOf" srcId="{32600481-437B-4F55-AD2F-74639178C1B2}" destId="{1483427B-D1AE-476D-B17F-92275D42378B}" srcOrd="0" destOrd="0" presId="urn:microsoft.com/office/officeart/2008/layout/LinedList"/>
+    <dgm:cxn modelId="{AE15B853-8753-40C4-8D0C-0FD4B2ECA1C9}" srcId="{51ADB69E-CEEF-44BF-B03A-EB79CD9E8062}" destId="{BC531E73-28AB-48EC-A683-6689A3A9F2E5}" srcOrd="3" destOrd="0" parTransId="{58229E09-91CB-4695-B79F-40352661C885}" sibTransId="{ABC83B8E-F8CA-416C-AD4F-302D0C50E9E1}"/>
     <dgm:cxn modelId="{40C6FC62-E4DD-4E15-A468-AF1D42FD8E4D}" srcId="{51ADB69E-CEEF-44BF-B03A-EB79CD9E8062}" destId="{2FD59555-E9ED-4235-8884-22DE78453B97}" srcOrd="2" destOrd="0" parTransId="{CDB05BB7-CBF1-4A2B-ACFB-6E9AE7429FE2}" sibTransId="{351019C0-5EFD-4D89-905D-87785A34320C}"/>
     <dgm:cxn modelId="{2218B76A-0FDD-4388-B3EE-A23B117172D0}" type="presOf" srcId="{7CA9E791-5EAA-44E6-BF77-78B5E304431C}" destId="{711FA85E-2EA5-4AC4-AB5F-520E841BC4CF}" srcOrd="0" destOrd="0" presId="urn:microsoft.com/office/officeart/2008/layout/LinedList"/>
     <dgm:cxn modelId="{FBB1F26E-B37A-44BD-8F43-FED90C4ADC9D}" srcId="{51ADB69E-CEEF-44BF-B03A-EB79CD9E8062}" destId="{5567816E-A4CC-4260-B4D8-5B271B459497}" srcOrd="1" destOrd="0" parTransId="{61D58984-0199-4010-B407-C31DA36D102E}" sibTransId="{339B5629-E286-4296-8D70-05CC90E2A637}"/>
-    <dgm:cxn modelId="{4B4B9D53-D3B2-49CA-835A-749A3CC976F2}" type="presOf" srcId="{32600481-437B-4F55-AD2F-74639178C1B2}" destId="{1483427B-D1AE-476D-B17F-92275D42378B}" srcOrd="0" destOrd="0" presId="urn:microsoft.com/office/officeart/2008/layout/LinedList"/>
-    <dgm:cxn modelId="{AE15B853-8753-40C4-8D0C-0FD4B2ECA1C9}" srcId="{51ADB69E-CEEF-44BF-B03A-EB79CD9E8062}" destId="{BC531E73-28AB-48EC-A683-6689A3A9F2E5}" srcOrd="3" destOrd="0" parTransId="{58229E09-91CB-4695-B79F-40352661C885}" sibTransId="{ABC83B8E-F8CA-416C-AD4F-302D0C50E9E1}"/>
     <dgm:cxn modelId="{A83C7876-5493-426E-BE7D-603439AA657F}" type="presOf" srcId="{2FD59555-E9ED-4235-8884-22DE78453B97}" destId="{7EB087D0-006C-4F5A-981C-F7DEBC3A3B82}" srcOrd="0" destOrd="0" presId="urn:microsoft.com/office/officeart/2008/layout/LinedList"/>
     <dgm:cxn modelId="{75BC2A7A-6F7A-4AF3-AEAC-81E93D417B61}" srcId="{1F197BB0-DC43-462E-A2C0-15EF4FC38EDE}" destId="{51ADB69E-CEEF-44BF-B03A-EB79CD9E8062}" srcOrd="2" destOrd="0" parTransId="{59381924-B3E3-4C94-B1AF-92710EF8B717}" sibTransId="{7FFF01D8-DFA5-4FB3-86B1-9F93E448664D}"/>
     <dgm:cxn modelId="{C04A617B-3783-4CC0-B13B-78B74796C23F}" srcId="{B225895E-D4C5-4180-A1B7-0E99C9B8EB4F}" destId="{1B011FFA-D01F-4553-A34C-B812C48BF077}" srcOrd="3" destOrd="0" parTransId="{760CD6D8-8390-4F94-A776-9F9DEFF52FD6}" sibTransId="{01A5218A-3C5B-4A44-91EF-BA9AB4F839B7}"/>
@@ -4912,10 +4912,10 @@
             <a:buNone/>
           </a:pPr>
           <a:r>
-            <a:rPr lang="de-CH" sz="1500" kern="1200"/>
+            <a:rPr lang="de-CH" sz="1500" kern="1200" dirty="0"/>
             <a:t>Typ wird über Struktur / Methoden erkannt</a:t>
           </a:r>
-          <a:endParaRPr lang="en-US" sz="1500" kern="1200"/>
+          <a:endParaRPr lang="en-US" sz="1500" kern="1200" dirty="0"/>
         </a:p>
       </dsp:txBody>
       <dsp:txXfrm>
@@ -12728,7 +12728,7 @@
           <a:p>
             <a:fld id="{D9EF2C90-E8EE-43CD-8D96-4E8A72565517}" type="datetimeFigureOut">
               <a:rPr lang="de-CH" smtClean="0"/>
-              <a:t>18.05.2026</a:t>
+              <a:t>19.05.26</a:t>
             </a:fld>
             <a:endParaRPr lang="de-CH"/>
           </a:p>
@@ -12887,7 +12887,7 @@
           <a:p>
             <a:fld id="{62945742-DB6B-4CE6-B846-92E01489719F}" type="slidenum">
               <a:rPr lang="de-CH" smtClean="0"/>
-              <a:t>‹Nr.›</a:t>
+              <a:t>‹#›</a:t>
             </a:fld>
             <a:endParaRPr lang="de-CH"/>
           </a:p>
@@ -13805,7 +13805,7 @@
           <a:p>
             <a:fld id="{5BCAD085-E8A6-8845-BD4E-CB4CCA059FC4}" type="datetimeFigureOut">
               <a:rPr lang="en-US" smtClean="0"/>
-              <a:t>5/18/2026</a:t>
+              <a:t>5/19/26</a:t>
             </a:fld>
             <a:endParaRPr lang="en-US"/>
           </a:p>
@@ -13847,7 +13847,7 @@
           <a:p>
             <a:fld id="{C1FF6DA9-008F-8B48-92A6-B652298478BF}" type="slidenum">
               <a:rPr lang="en-US" smtClean="0"/>
-              <a:t>‹Nr.›</a:t>
+              <a:t>‹#›</a:t>
             </a:fld>
             <a:endParaRPr lang="en-US"/>
           </a:p>
@@ -13973,7 +13973,7 @@
           <a:p>
             <a:fld id="{5BCAD085-E8A6-8845-BD4E-CB4CCA059FC4}" type="datetimeFigureOut">
               <a:rPr lang="en-US" smtClean="0"/>
-              <a:t>5/18/2026</a:t>
+              <a:t>5/19/26</a:t>
             </a:fld>
             <a:endParaRPr lang="en-US"/>
           </a:p>
@@ -14015,7 +14015,7 @@
           <a:p>
             <a:fld id="{C1FF6DA9-008F-8B48-92A6-B652298478BF}" type="slidenum">
               <a:rPr lang="en-US" smtClean="0"/>
-              <a:t>‹Nr.›</a:t>
+              <a:t>‹#›</a:t>
             </a:fld>
             <a:endParaRPr lang="en-US"/>
           </a:p>
@@ -14151,7 +14151,7 @@
           <a:p>
             <a:fld id="{5BCAD085-E8A6-8845-BD4E-CB4CCA059FC4}" type="datetimeFigureOut">
               <a:rPr lang="en-US" smtClean="0"/>
-              <a:t>5/18/2026</a:t>
+              <a:t>5/19/26</a:t>
             </a:fld>
             <a:endParaRPr lang="en-US"/>
           </a:p>
@@ -14193,7 +14193,7 @@
           <a:p>
             <a:fld id="{C1FF6DA9-008F-8B48-92A6-B652298478BF}" type="slidenum">
               <a:rPr lang="en-US" smtClean="0"/>
-              <a:t>‹Nr.›</a:t>
+              <a:t>‹#›</a:t>
             </a:fld>
             <a:endParaRPr lang="en-US"/>
           </a:p>
@@ -14319,7 +14319,7 @@
           <a:p>
             <a:fld id="{5BCAD085-E8A6-8845-BD4E-CB4CCA059FC4}" type="datetimeFigureOut">
               <a:rPr lang="en-US" smtClean="0"/>
-              <a:t>5/18/2026</a:t>
+              <a:t>5/19/26</a:t>
             </a:fld>
             <a:endParaRPr lang="en-US"/>
           </a:p>
@@ -14361,7 +14361,7 @@
           <a:p>
             <a:fld id="{C1FF6DA9-008F-8B48-92A6-B652298478BF}" type="slidenum">
               <a:rPr lang="en-US" smtClean="0"/>
-              <a:t>‹Nr.›</a:t>
+              <a:t>‹#›</a:t>
             </a:fld>
             <a:endParaRPr lang="en-US"/>
           </a:p>
@@ -14564,7 +14564,7 @@
           <a:p>
             <a:fld id="{5BCAD085-E8A6-8845-BD4E-CB4CCA059FC4}" type="datetimeFigureOut">
               <a:rPr lang="en-US" smtClean="0"/>
-              <a:t>5/18/2026</a:t>
+              <a:t>5/19/26</a:t>
             </a:fld>
             <a:endParaRPr lang="en-US"/>
           </a:p>
@@ -14606,7 +14606,7 @@
           <a:p>
             <a:fld id="{C1FF6DA9-008F-8B48-92A6-B652298478BF}" type="slidenum">
               <a:rPr lang="en-US" smtClean="0"/>
-              <a:t>‹Nr.›</a:t>
+              <a:t>‹#›</a:t>
             </a:fld>
             <a:endParaRPr lang="en-US"/>
           </a:p>
@@ -14849,7 +14849,7 @@
           <a:p>
             <a:fld id="{5BCAD085-E8A6-8845-BD4E-CB4CCA059FC4}" type="datetimeFigureOut">
               <a:rPr lang="en-US" smtClean="0"/>
-              <a:t>5/18/2026</a:t>
+              <a:t>5/19/26</a:t>
             </a:fld>
             <a:endParaRPr lang="en-US"/>
           </a:p>
@@ -14891,7 +14891,7 @@
           <a:p>
             <a:fld id="{C1FF6DA9-008F-8B48-92A6-B652298478BF}" type="slidenum">
               <a:rPr lang="en-US" smtClean="0"/>
-              <a:t>‹Nr.›</a:t>
+              <a:t>‹#›</a:t>
             </a:fld>
             <a:endParaRPr lang="en-US"/>
           </a:p>
@@ -15268,7 +15268,7 @@
           <a:p>
             <a:fld id="{5BCAD085-E8A6-8845-BD4E-CB4CCA059FC4}" type="datetimeFigureOut">
               <a:rPr lang="en-US" smtClean="0"/>
-              <a:t>5/18/2026</a:t>
+              <a:t>5/19/26</a:t>
             </a:fld>
             <a:endParaRPr lang="en-US"/>
           </a:p>
@@ -15310,7 +15310,7 @@
           <a:p>
             <a:fld id="{C1FF6DA9-008F-8B48-92A6-B652298478BF}" type="slidenum">
               <a:rPr lang="en-US" smtClean="0"/>
-              <a:t>‹Nr.›</a:t>
+              <a:t>‹#›</a:t>
             </a:fld>
             <a:endParaRPr lang="en-US"/>
           </a:p>
@@ -15385,7 +15385,7 @@
           <a:p>
             <a:fld id="{5BCAD085-E8A6-8845-BD4E-CB4CCA059FC4}" type="datetimeFigureOut">
               <a:rPr lang="en-US" smtClean="0"/>
-              <a:t>5/18/2026</a:t>
+              <a:t>5/19/26</a:t>
             </a:fld>
             <a:endParaRPr lang="en-US"/>
           </a:p>
@@ -15427,7 +15427,7 @@
           <a:p>
             <a:fld id="{C1FF6DA9-008F-8B48-92A6-B652298478BF}" type="slidenum">
               <a:rPr lang="en-US" smtClean="0"/>
-              <a:t>‹Nr.›</a:t>
+              <a:t>‹#›</a:t>
             </a:fld>
             <a:endParaRPr lang="en-US"/>
           </a:p>
@@ -15480,7 +15480,7 @@
           <a:p>
             <a:fld id="{5BCAD085-E8A6-8845-BD4E-CB4CCA059FC4}" type="datetimeFigureOut">
               <a:rPr lang="en-US" smtClean="0"/>
-              <a:t>5/18/2026</a:t>
+              <a:t>5/19/26</a:t>
             </a:fld>
             <a:endParaRPr lang="en-US"/>
           </a:p>
@@ -15522,7 +15522,7 @@
           <a:p>
             <a:fld id="{C1FF6DA9-008F-8B48-92A6-B652298478BF}" type="slidenum">
               <a:rPr lang="en-US" smtClean="0"/>
-              <a:t>‹Nr.›</a:t>
+              <a:t>‹#›</a:t>
             </a:fld>
             <a:endParaRPr lang="en-US"/>
           </a:p>
@@ -15755,7 +15755,7 @@
           <a:p>
             <a:fld id="{5BCAD085-E8A6-8845-BD4E-CB4CCA059FC4}" type="datetimeFigureOut">
               <a:rPr lang="en-US" smtClean="0"/>
-              <a:t>5/18/2026</a:t>
+              <a:t>5/19/26</a:t>
             </a:fld>
             <a:endParaRPr lang="en-US"/>
           </a:p>
@@ -15797,7 +15797,7 @@
           <a:p>
             <a:fld id="{C1FF6DA9-008F-8B48-92A6-B652298478BF}" type="slidenum">
               <a:rPr lang="en-US" smtClean="0"/>
-              <a:t>‹Nr.›</a:t>
+              <a:t>‹#›</a:t>
             </a:fld>
             <a:endParaRPr lang="en-US"/>
           </a:p>
@@ -16007,7 +16007,7 @@
           <a:p>
             <a:fld id="{5BCAD085-E8A6-8845-BD4E-CB4CCA059FC4}" type="datetimeFigureOut">
               <a:rPr lang="en-US" smtClean="0"/>
-              <a:t>5/18/2026</a:t>
+              <a:t>5/19/26</a:t>
             </a:fld>
             <a:endParaRPr lang="en-US"/>
           </a:p>
@@ -16049,7 +16049,7 @@
           <a:p>
             <a:fld id="{C1FF6DA9-008F-8B48-92A6-B652298478BF}" type="slidenum">
               <a:rPr lang="en-US" smtClean="0"/>
-              <a:t>‹Nr.›</a:t>
+              <a:t>‹#›</a:t>
             </a:fld>
             <a:endParaRPr lang="en-US"/>
           </a:p>
@@ -16218,7 +16218,7 @@
           <a:p>
             <a:fld id="{5BCAD085-E8A6-8845-BD4E-CB4CCA059FC4}" type="datetimeFigureOut">
               <a:rPr lang="en-US" smtClean="0"/>
-              <a:t>5/18/2026</a:t>
+              <a:t>5/19/26</a:t>
             </a:fld>
             <a:endParaRPr lang="en-US"/>
           </a:p>
@@ -16296,7 +16296,7 @@
           <a:p>
             <a:fld id="{C1FF6DA9-008F-8B48-92A6-B652298478BF}" type="slidenum">
               <a:rPr lang="en-US" smtClean="0"/>
-              <a:t>‹Nr.›</a:t>
+              <a:t>‹#›</a:t>
             </a:fld>
             <a:endParaRPr lang="en-US"/>
           </a:p>
@@ -17594,15 +17594,7 @@
             </a:r>
             <a:r>
               <a:rPr lang="de-CH" sz="2100" dirty="0"/>
-              <a:t> werden </a:t>
-            </a:r>
-            <a:r>
-              <a:rPr lang="de-CH" sz="2100" dirty="0" err="1"/>
-              <a:t>rücktwärts</a:t>
-            </a:r>
-            <a:r>
-              <a:rPr lang="de-CH" sz="2100" dirty="0"/>
-              <a:t> ausgeführt (LIFO)</a:t>
+              <a:t> werden rückwärts ausgeführt (LIFO aka Stack)</a:t>
             </a:r>
           </a:p>
           <a:p>
@@ -17695,13 +17687,8 @@
             </a:r>
             <a:r>
               <a:rPr lang="de-CH" sz="2100" dirty="0"/>
-              <a:t> und gibt Panic-Wert </a:t>
+              <a:t> und gibt Panic-Wert zurück</a:t>
             </a:r>
-            <a:r>
-              <a:rPr lang="de-CH" sz="2100" dirty="0" err="1"/>
-              <a:t>züruck</a:t>
-            </a:r>
-            <a:endParaRPr lang="de-CH" sz="2100" dirty="0"/>
           </a:p>
         </p:txBody>
       </p:sp>
@@ -23756,8 +23743,13 @@
             </a:pPr>
             <a:r>
               <a:rPr lang="de-CH" sz="2100" dirty="0"/>
-              <a:t>GO verwendet Zeiger, verzichtet jedoch auf Zeigerarithmetik</a:t>
+              <a:t>GO verwendet Pointers, verzichtet jedoch auf </a:t>
             </a:r>
+            <a:r>
+              <a:rPr lang="de-CH" sz="2100" dirty="0" err="1"/>
+              <a:t>Pointerarithmetik</a:t>
+            </a:r>
+            <a:endParaRPr lang="de-CH" sz="2100" dirty="0"/>
           </a:p>
           <a:p>
             <a:pPr marL="0" indent="0">
@@ -25240,7 +25232,7 @@
             </a:r>
             <a:r>
               <a:rPr lang="de-CH" sz="2100" dirty="0" err="1"/>
-              <a:t>Structur</a:t>
+              <a:t>Structure</a:t>
             </a:r>
             <a:endParaRPr lang="de-CH" sz="2100" dirty="0"/>
           </a:p>

</xml_diff>